<commit_message>
Letzte Features eingebaut, Doku dieses mal wirklich abgeschlossen
</commit_message>
<xml_diff>
--- a/docs/notebookTools.pptx
+++ b/docs/notebookTools.pptx
@@ -1560,7 +1560,7 @@
                 <a:ea typeface="Calibri" pitchFamily="34" charset="-122"/>
                 <a:cs typeface="Calibri" pitchFamily="34" charset="-120"/>
               </a:rPr>
-              <a:t>Zellen bearbeiten, hinzufügen, löschen und verschieben</a:t>
+              <a:t>Zellen bearbeiten, einfügen, löschen, verschieben und Typ ändern</a:t>
             </a:r>
             <a:endParaRPr lang="en-US" sz="2200" dirty="0"/>
           </a:p>
@@ -1581,7 +1581,7 @@
                 <a:ea typeface="Calibri" pitchFamily="34" charset="-122"/>
                 <a:cs typeface="Calibri" pitchFamily="34" charset="-120"/>
               </a:rPr>
-              <a:t>Notebooks zusammenführen und neu speichern</a:t>
+              <a:t>Zellen aufteilen, zusammenführen und Notebooks neu speichern</a:t>
             </a:r>
             <a:endParaRPr lang="en-US" sz="2200" dirty="0"/>
           </a:p>
@@ -1644,7 +1644,7 @@
                 <a:ea typeface="Calibri" pitchFamily="34" charset="-122"/>
                 <a:cs typeface="Calibri" pitchFamily="34" charset="-120"/>
               </a:rPr>
-              <a:t>Unit Tests für wichtige Funktionen</a:t>
+              <a:t>Unit Tests und Export als TXT, HTML und DOCX</a:t>
             </a:r>
             <a:endParaRPr lang="en-US" sz="2200" dirty="0"/>
           </a:p>

</xml_diff>

<commit_message>
Finale Änderungen und alles nötige und wichtige ins Repo aufgenommen
</commit_message>
<xml_diff>
--- a/docs/notebookTools.pptx
+++ b/docs/notebookTools.pptx
@@ -5,7 +5,7 @@
     <p:sldMasterId id="2147483648" r:id="rId1"/>
   </p:sldMasterIdLst>
   <p:notesMasterIdLst>
-    <p:notesMasterId r:id="rId8"/>
+    <p:notesMasterId r:id="rId10"/>
   </p:notesMasterIdLst>
   <p:sldIdLst>
     <p:sldId id="256" r:id="rId2"/>
@@ -13,7 +13,9 @@
     <p:sldId id="258" r:id="rId4"/>
     <p:sldId id="259" r:id="rId5"/>
     <p:sldId id="260" r:id="rId6"/>
-    <p:sldId id="261" r:id="rId7"/>
+    <p:sldId id="262" r:id="rId7"/>
+    <p:sldId id="263" r:id="rId8"/>
+    <p:sldId id="261" r:id="rId9"/>
   </p:sldIdLst>
   <p:sldSz cx="9144000" cy="5143500" type="screen16x9"/>
   <p:notesSz cx="5143500" cy="9144000"/>
@@ -727,7 +729,7 @@
           <a:p>
             <a:fld id="{F7021451-1387-4CA6-816F-3879F97B5CBC}" type="slidenum">
               <a:rPr lang="en-US"/>
-              <a:t>6</a:t>
+              <a:t>8</a:t>
             </a:fld>
             <a:endParaRPr lang="en-US"/>
           </a:p>
@@ -1299,6 +1301,13 @@
             <a:prstDash val="solid"/>
           </a:ln>
         </p:spPr>
+        <p:txBody>
+          <a:bodyPr/>
+          <a:lstStyle/>
+          <a:p>
+            <a:endParaRPr lang="de-DE"/>
+          </a:p>
+        </p:txBody>
       </p:sp>
       <p:sp>
         <p:nvSpPr>
@@ -1480,6 +1489,13 @@
             <a:prstDash val="solid"/>
           </a:ln>
         </p:spPr>
+        <p:txBody>
+          <a:bodyPr/>
+          <a:lstStyle/>
+          <a:p>
+            <a:endParaRPr lang="de-DE"/>
+          </a:p>
+        </p:txBody>
       </p:sp>
       <p:sp>
         <p:nvSpPr>
@@ -1746,6 +1762,13 @@
             <a:prstDash val="solid"/>
           </a:ln>
         </p:spPr>
+        <p:txBody>
+          <a:bodyPr/>
+          <a:lstStyle/>
+          <a:p>
+            <a:endParaRPr lang="de-DE"/>
+          </a:p>
+        </p:txBody>
       </p:sp>
       <p:sp>
         <p:nvSpPr>
@@ -1773,6 +1796,13 @@
             <a:prstDash val="solid"/>
           </a:ln>
         </p:spPr>
+        <p:txBody>
+          <a:bodyPr/>
+          <a:lstStyle/>
+          <a:p>
+            <a:endParaRPr lang="de-DE"/>
+          </a:p>
+        </p:txBody>
       </p:sp>
       <p:sp>
         <p:nvSpPr>
@@ -1878,6 +1908,13 @@
             <a:prstDash val="solid"/>
           </a:ln>
         </p:spPr>
+        <p:txBody>
+          <a:bodyPr/>
+          <a:lstStyle/>
+          <a:p>
+            <a:endParaRPr lang="de-DE"/>
+          </a:p>
+        </p:txBody>
       </p:sp>
       <p:sp>
         <p:nvSpPr>
@@ -2081,6 +2118,13 @@
             <a:prstDash val="solid"/>
           </a:ln>
         </p:spPr>
+        <p:txBody>
+          <a:bodyPr/>
+          <a:lstStyle/>
+          <a:p>
+            <a:endParaRPr lang="de-DE"/>
+          </a:p>
+        </p:txBody>
       </p:sp>
       <p:sp>
         <p:nvSpPr>
@@ -2143,6 +2187,575 @@
 </file>
 
 <file path=ppt/slides/slide6.xml><?xml version="1.0" encoding="utf-8"?>
+<p:sld xmlns:a="http://schemas.openxmlformats.org/drawingml/2006/main" xmlns:r="http://schemas.openxmlformats.org/officeDocument/2006/relationships" xmlns:p="http://schemas.openxmlformats.org/presentationml/2006/main">
+  <p:cSld name="Slide 7">
+    <p:bg>
+      <p:bgPr>
+        <a:solidFill>
+          <a:srgbClr val="0D1117"/>
+        </a:solidFill>
+        <a:effectLst/>
+      </p:bgPr>
+    </p:bg>
+    <p:spTree>
+      <p:nvGrpSpPr>
+        <p:cNvPr id="1" name=""/>
+        <p:cNvGrpSpPr/>
+        <p:nvPr/>
+      </p:nvGrpSpPr>
+      <p:grpSpPr>
+        <a:xfrm>
+          <a:off x="0" y="0"/>
+          <a:ext cx="0" cy="0"/>
+          <a:chOff x="0" y="0"/>
+          <a:chExt cx="0" cy="0"/>
+        </a:xfrm>
+      </p:grpSpPr>
+      <p:sp>
+        <p:nvSpPr>
+          <p:cNvPr id="2" name="Text 0"/>
+          <p:cNvSpPr txBox="1"/>
+          <p:nvPr/>
+        </p:nvSpPr>
+        <p:spPr>
+          <a:xfrm>
+            <a:off x="548640" y="365760"/>
+            <a:ext cx="8046720" cy="640080"/>
+          </a:xfrm>
+          <a:prstGeom prst="rect">
+            <a:avLst/>
+          </a:prstGeom>
+          <a:noFill/>
+          <a:ln/>
+        </p:spPr>
+        <p:txBody>
+          <a:bodyPr wrap="square" lIns="0" tIns="0" rIns="0" bIns="0" rtlCol="0" anchor="ctr"/>
+          <a:lstStyle/>
+          <a:p>
+            <a:pPr marL="0" indent="0">
+              <a:buNone/>
+            </a:pPr>
+            <a:r>
+              <a:rPr lang="en-US" sz="3200" b="1" dirty="0">
+                <a:solidFill>
+                  <a:srgbClr val="E6EDF3"/>
+                </a:solidFill>
+                <a:latin typeface="Calibri" pitchFamily="34" charset="0"/>
+                <a:ea typeface="Calibri" pitchFamily="34" charset="-122"/>
+                <a:cs typeface="Calibri" pitchFamily="34" charset="-120"/>
+              </a:rPr>
+              <a:t>Wichtige Codestellen</a:t>
+            </a:r>
+            <a:endParaRPr lang="en-US" sz="3200" dirty="0"/>
+          </a:p>
+        </p:txBody>
+      </p:sp>
+      <p:sp>
+        <p:nvSpPr>
+          <p:cNvPr id="3" name="Shape 1"/>
+          <p:cNvSpPr/>
+          <p:nvPr/>
+        </p:nvSpPr>
+        <p:spPr>
+          <a:xfrm>
+            <a:off x="548640" y="1051560"/>
+            <a:ext cx="3504850" cy="54864"/>
+          </a:xfrm>
+          <a:prstGeom prst="rect">
+            <a:avLst/>
+          </a:prstGeom>
+          <a:solidFill>
+            <a:srgbClr val="58A6FF"/>
+          </a:solidFill>
+          <a:ln w="12700">
+            <a:solidFill>
+              <a:srgbClr val="58A6FF"/>
+            </a:solidFill>
+            <a:prstDash val="solid"/>
+          </a:ln>
+        </p:spPr>
+        <p:txBody>
+          <a:bodyPr/>
+          <a:lstStyle/>
+          <a:p>
+            <a:endParaRPr lang="de-DE"/>
+          </a:p>
+        </p:txBody>
+      </p:sp>
+      <p:sp>
+        <p:nvSpPr>
+          <p:cNvPr id="4" name="Text 2"/>
+          <p:cNvSpPr txBox="1"/>
+          <p:nvPr/>
+        </p:nvSpPr>
+        <p:spPr>
+          <a:xfrm>
+            <a:off x="548640" y="1417320"/>
+            <a:ext cx="8046720" cy="3291840"/>
+          </a:xfrm>
+          <a:prstGeom prst="rect">
+            <a:avLst/>
+          </a:prstGeom>
+          <a:noFill/>
+          <a:ln/>
+        </p:spPr>
+        <p:txBody>
+          <a:bodyPr wrap="square" lIns="0" tIns="0" rIns="0" bIns="0" rtlCol="0" anchor="t"/>
+          <a:lstStyle/>
+          <a:p>
+            <a:pPr marL="342900" indent="-342900">
+              <a:spcAft>
+                <a:spcPts val="800"/>
+              </a:spcAft>
+              <a:buSzPct val="100000"/>
+              <a:buChar char="•"/>
+            </a:pPr>
+            <a:r>
+              <a:rPr lang="en-US" sz="2200" dirty="0">
+                <a:solidFill>
+                  <a:srgbClr val="E6EDF3"/>
+                </a:solidFill>
+                <a:latin typeface="Calibri" pitchFamily="34" charset="0"/>
+                <a:ea typeface="Calibri" pitchFamily="34" charset="-122"/>
+                <a:cs typeface="Calibri" pitchFamily="34" charset="-120"/>
+              </a:rPr>
+              <a:t>NotebookReader: JSON in C#-Objekte einlesen</a:t>
+            </a:r>
+            <a:endParaRPr lang="en-US" sz="2200" dirty="0"/>
+          </a:p>
+          <a:p>
+            <a:pPr marL="342900" indent="-342900">
+              <a:spcAft>
+                <a:spcPts val="800"/>
+              </a:spcAft>
+              <a:buSzPct val="100000"/>
+              <a:buChar char="•"/>
+            </a:pPr>
+            <a:r>
+              <a:rPr lang="en-US" sz="2200" dirty="0">
+                <a:solidFill>
+                  <a:srgbClr val="E6EDF3"/>
+                </a:solidFill>
+                <a:latin typeface="Calibri" pitchFamily="34" charset="0"/>
+                <a:ea typeface="Calibri" pitchFamily="34" charset="-122"/>
+                <a:cs typeface="Calibri" pitchFamily="34" charset="-120"/>
+              </a:rPr>
+              <a:t>CommandShow: source mit Schleifen auslesen</a:t>
+            </a:r>
+            <a:endParaRPr lang="en-US" sz="2200" dirty="0"/>
+          </a:p>
+          <a:p>
+            <a:pPr marL="342900" indent="-342900">
+              <a:spcAft>
+                <a:spcPts val="800"/>
+              </a:spcAft>
+              <a:buSzPct val="100000"/>
+              <a:buChar char="•"/>
+            </a:pPr>
+            <a:r>
+              <a:rPr lang="en-US" sz="2200" dirty="0">
+                <a:solidFill>
+                  <a:srgbClr val="E6EDF3"/>
+                </a:solidFill>
+                <a:latin typeface="Calibri" pitchFamily="34" charset="0"/>
+                <a:ea typeface="Calibri" pitchFamily="34" charset="-122"/>
+                <a:cs typeface="Calibri" pitchFamily="34" charset="-120"/>
+              </a:rPr>
+              <a:t>CommandContent: Zelltext auf 80 Zeichen kürzen</a:t>
+            </a:r>
+            <a:endParaRPr lang="en-US" sz="2200" dirty="0"/>
+          </a:p>
+          <a:p>
+            <a:pPr marL="342900" indent="-342900">
+              <a:spcAft>
+                <a:spcPts val="800"/>
+              </a:spcAft>
+              <a:buSzPct val="100000"/>
+              <a:buChar char="•"/>
+            </a:pPr>
+            <a:r>
+              <a:rPr lang="en-US" sz="2200" dirty="0">
+                <a:solidFill>
+                  <a:srgbClr val="E6EDF3"/>
+                </a:solidFill>
+                <a:latin typeface="Calibri" pitchFamily="34" charset="0"/>
+                <a:ea typeface="Calibri" pitchFamily="34" charset="-122"/>
+                <a:cs typeface="Calibri" pitchFamily="34" charset="-120"/>
+              </a:rPr>
+              <a:t>CellEditor: eine Zelle im temporären Notebook bearbeiten</a:t>
+            </a:r>
+            <a:endParaRPr lang="en-US" sz="2200" dirty="0"/>
+          </a:p>
+          <a:p>
+            <a:pPr marL="342900" indent="-342900">
+              <a:spcAft>
+                <a:spcPts val="800"/>
+              </a:spcAft>
+              <a:buSzPct val="100000"/>
+              <a:buChar char="•"/>
+            </a:pPr>
+            <a:r>
+              <a:rPr lang="en-US" sz="2200" dirty="0">
+                <a:solidFill>
+                  <a:srgbClr val="E6EDF3"/>
+                </a:solidFill>
+                <a:latin typeface="Calibri" pitchFamily="34" charset="0"/>
+                <a:ea typeface="Calibri" pitchFamily="34" charset="-122"/>
+                <a:cs typeface="Calibri" pitchFamily="34" charset="-120"/>
+              </a:rPr>
+              <a:t>CommandSave: in neue Datei speichern, Original behalten</a:t>
+            </a:r>
+            <a:endParaRPr lang="en-US" sz="2200" dirty="0"/>
+          </a:p>
+          <a:p>
+            <a:pPr marL="342900" indent="-342900">
+              <a:spcAft>
+                <a:spcPts val="800"/>
+              </a:spcAft>
+              <a:buSzPct val="100000"/>
+              <a:buChar char="•"/>
+            </a:pPr>
+            <a:r>
+              <a:rPr lang="en-US" sz="2200" dirty="0">
+                <a:solidFill>
+                  <a:srgbClr val="E6EDF3"/>
+                </a:solidFill>
+                <a:latin typeface="Calibri" pitchFamily="34" charset="0"/>
+                <a:ea typeface="Calibri" pitchFamily="34" charset="-122"/>
+                <a:cs typeface="Calibri" pitchFamily="34" charset="-120"/>
+              </a:rPr>
+              <a:t>NotebookWriter: Metadaten und Zell-IDs erhalten</a:t>
+            </a:r>
+            <a:endParaRPr lang="en-US" sz="2200" dirty="0"/>
+          </a:p>
+          <a:p>
+            <a:pPr marL="342900" indent="-342900">
+              <a:spcAft>
+                <a:spcPts val="800"/>
+              </a:spcAft>
+              <a:buSzPct val="100000"/>
+              <a:buChar char="•"/>
+            </a:pPr>
+            <a:r>
+              <a:rPr lang="en-US" sz="2200" dirty="0">
+                <a:solidFill>
+                  <a:srgbClr val="E6EDF3"/>
+                </a:solidFill>
+                <a:latin typeface="Calibri" pitchFamily="34" charset="0"/>
+                <a:ea typeface="Calibri" pitchFamily="34" charset="-122"/>
+                <a:cs typeface="Calibri" pitchFamily="34" charset="-120"/>
+              </a:rPr>
+              <a:t>Tests: gültige Eingaben und Fehlerfälle prüfen</a:t>
+            </a:r>
+            <a:endParaRPr lang="en-US" sz="2200" dirty="0"/>
+          </a:p>
+        </p:txBody>
+      </p:sp>
+    </p:spTree>
+  </p:cSld>
+  <p:clrMapOvr>
+    <a:masterClrMapping/>
+  </p:clrMapOvr>
+</p:sld>
+</file>
+
+<file path=ppt/slides/slide7.xml><?xml version="1.0" encoding="utf-8"?>
+<p:sld xmlns:a="http://schemas.openxmlformats.org/drawingml/2006/main" xmlns:r="http://schemas.openxmlformats.org/officeDocument/2006/relationships" xmlns:p="http://schemas.openxmlformats.org/presentationml/2006/main">
+  <p:cSld name="Slide 8">
+    <p:bg>
+      <p:bgPr>
+        <a:solidFill>
+          <a:srgbClr val="0D1117"/>
+        </a:solidFill>
+        <a:effectLst/>
+      </p:bgPr>
+    </p:bg>
+    <p:spTree>
+      <p:nvGrpSpPr>
+        <p:cNvPr id="1" name=""/>
+        <p:cNvGrpSpPr/>
+        <p:nvPr/>
+      </p:nvGrpSpPr>
+      <p:grpSpPr>
+        <a:xfrm>
+          <a:off x="0" y="0"/>
+          <a:ext cx="0" cy="0"/>
+          <a:chOff x="0" y="0"/>
+          <a:chExt cx="0" cy="0"/>
+        </a:xfrm>
+      </p:grpSpPr>
+      <p:sp>
+        <p:nvSpPr>
+          <p:cNvPr id="2" name="Text 0"/>
+          <p:cNvSpPr txBox="1"/>
+          <p:nvPr/>
+        </p:nvSpPr>
+        <p:spPr>
+          <a:xfrm>
+            <a:off x="548640" y="365760"/>
+            <a:ext cx="8046720" cy="640080"/>
+          </a:xfrm>
+          <a:prstGeom prst="rect">
+            <a:avLst/>
+          </a:prstGeom>
+          <a:noFill/>
+          <a:ln/>
+        </p:spPr>
+        <p:txBody>
+          <a:bodyPr wrap="square" lIns="0" tIns="0" rIns="0" bIns="0" rtlCol="0" anchor="ctr"/>
+          <a:lstStyle/>
+          <a:p>
+            <a:pPr marL="0" indent="0">
+              <a:buNone/>
+            </a:pPr>
+            <a:r>
+              <a:rPr lang="en-US" sz="3200" b="1" dirty="0">
+                <a:solidFill>
+                  <a:srgbClr val="E6EDF3"/>
+                </a:solidFill>
+                <a:latin typeface="Calibri" pitchFamily="34" charset="0"/>
+                <a:ea typeface="Calibri" pitchFamily="34" charset="-122"/>
+                <a:cs typeface="Calibri" pitchFamily="34" charset="-120"/>
+              </a:rPr>
+              <a:t>Individuelle Beiträge</a:t>
+            </a:r>
+            <a:endParaRPr lang="en-US" sz="3200" dirty="0"/>
+          </a:p>
+        </p:txBody>
+      </p:sp>
+      <p:sp>
+        <p:nvSpPr>
+          <p:cNvPr id="3" name="Shape 1"/>
+          <p:cNvSpPr/>
+          <p:nvPr/>
+        </p:nvSpPr>
+        <p:spPr>
+          <a:xfrm>
+            <a:off x="548640" y="1051560"/>
+            <a:ext cx="3504850" cy="54864"/>
+          </a:xfrm>
+          <a:prstGeom prst="rect">
+            <a:avLst/>
+          </a:prstGeom>
+          <a:solidFill>
+            <a:srgbClr val="58A6FF"/>
+          </a:solidFill>
+          <a:ln w="12700">
+            <a:solidFill>
+              <a:srgbClr val="58A6FF"/>
+            </a:solidFill>
+            <a:prstDash val="solid"/>
+          </a:ln>
+        </p:spPr>
+        <p:txBody>
+          <a:bodyPr/>
+          <a:lstStyle/>
+          <a:p>
+            <a:endParaRPr lang="de-DE"/>
+          </a:p>
+        </p:txBody>
+      </p:sp>
+      <p:sp>
+        <p:nvSpPr>
+          <p:cNvPr id="4" name="Text 2"/>
+          <p:cNvSpPr txBox="1"/>
+          <p:nvPr/>
+        </p:nvSpPr>
+        <p:spPr>
+          <a:xfrm>
+            <a:off x="548640" y="1417320"/>
+            <a:ext cx="8046720" cy="3291840"/>
+          </a:xfrm>
+          <a:prstGeom prst="rect">
+            <a:avLst/>
+          </a:prstGeom>
+          <a:noFill/>
+          <a:ln/>
+        </p:spPr>
+        <p:txBody>
+          <a:bodyPr wrap="square" lIns="0" tIns="0" rIns="0" bIns="0" rtlCol="0" anchor="t"/>
+          <a:lstStyle/>
+          <a:p>
+            <a:pPr marL="342900" indent="-342900">
+              <a:spcAft>
+                <a:spcPts val="800"/>
+              </a:spcAft>
+              <a:buSzPct val="100000"/>
+              <a:buChar char="•"/>
+            </a:pPr>
+            <a:r>
+              <a:rPr lang="en-US" sz="2200" dirty="0">
+                <a:solidFill>
+                  <a:srgbClr val="E6EDF3"/>
+                </a:solidFill>
+                <a:latin typeface="Calibri" pitchFamily="34" charset="0"/>
+                <a:ea typeface="Calibri" pitchFamily="34" charset="-122"/>
+                <a:cs typeface="Calibri" pitchFamily="34" charset="-120"/>
+              </a:rPr>
+              <a:t>Marius: Struktur, Dateisuche, Einlesen, Speichern und Merge</a:t>
+            </a:r>
+            <a:endParaRPr lang="en-US" sz="2200" dirty="0"/>
+          </a:p>
+          <a:p>
+            <a:pPr marL="342900" indent="-342900">
+              <a:spcAft>
+                <a:spcPts val="800"/>
+              </a:spcAft>
+              <a:buSzPct val="100000"/>
+              <a:buChar char="•"/>
+            </a:pPr>
+            <a:r>
+              <a:rPr lang="en-US" sz="2200" dirty="0">
+                <a:solidFill>
+                  <a:srgbClr val="E6EDF3"/>
+                </a:solidFill>
+                <a:latin typeface="Calibri" pitchFamily="34" charset="0"/>
+                <a:ea typeface="Calibri" pitchFamily="34" charset="-122"/>
+                <a:cs typeface="Calibri" pitchFamily="34" charset="-120"/>
+              </a:rPr>
+              <a:t>Marius: Export, Zelltyp, Split und Join</a:t>
+            </a:r>
+            <a:endParaRPr lang="en-US" sz="2200" dirty="0"/>
+          </a:p>
+          <a:p>
+            <a:pPr marL="342900" indent="-342900">
+              <a:spcAft>
+                <a:spcPts val="800"/>
+              </a:spcAft>
+              <a:buSzPct val="100000"/>
+              <a:buChar char="•"/>
+            </a:pPr>
+            <a:r>
+              <a:rPr lang="en-US" sz="2200" dirty="0">
+                <a:solidFill>
+                  <a:srgbClr val="E6EDF3"/>
+                </a:solidFill>
+                <a:latin typeface="Calibri" pitchFamily="34" charset="0"/>
+                <a:ea typeface="Calibri" pitchFamily="34" charset="-122"/>
+                <a:cs typeface="Calibri" pitchFamily="34" charset="-120"/>
+              </a:rPr>
+              <a:t>Jonas: show, Zellbearbeitung mit Marius</a:t>
+            </a:r>
+            <a:endParaRPr lang="en-US" sz="2200" dirty="0"/>
+          </a:p>
+          <a:p>
+            <a:pPr marL="342900" indent="-342900">
+              <a:spcAft>
+                <a:spcPts val="800"/>
+              </a:spcAft>
+              <a:buSzPct val="100000"/>
+              <a:buChar char="•"/>
+            </a:pPr>
+            <a:r>
+              <a:rPr lang="en-US" sz="2200" dirty="0">
+                <a:solidFill>
+                  <a:srgbClr val="E6EDF3"/>
+                </a:solidFill>
+                <a:latin typeface="Calibri" pitchFamily="34" charset="0"/>
+                <a:ea typeface="Calibri" pitchFamily="34" charset="-122"/>
+                <a:cs typeface="Calibri" pitchFamily="34" charset="-120"/>
+              </a:rPr>
+              <a:t>Catharina: content, add, Suchen/</a:t>
+            </a:r>
+            <a:r>
+              <a:rPr lang="en-US" sz="2200" dirty="0" err="1">
+                <a:solidFill>
+                  <a:srgbClr val="E6EDF3"/>
+                </a:solidFill>
+                <a:latin typeface="Calibri" pitchFamily="34" charset="0"/>
+                <a:ea typeface="Calibri" pitchFamily="34" charset="-122"/>
+                <a:cs typeface="Calibri" pitchFamily="34" charset="-120"/>
+              </a:rPr>
+              <a:t>Ersetzen</a:t>
+            </a:r>
+            <a:endParaRPr lang="en-US" sz="2200" dirty="0"/>
+          </a:p>
+          <a:p>
+            <a:pPr marL="342900" indent="-342900">
+              <a:spcAft>
+                <a:spcPts val="800"/>
+              </a:spcAft>
+              <a:buSzPct val="100000"/>
+              <a:buChar char="•"/>
+            </a:pPr>
+            <a:r>
+              <a:rPr lang="en-US" sz="2200" dirty="0">
+                <a:solidFill>
+                  <a:srgbClr val="E6EDF3"/>
+                </a:solidFill>
+                <a:latin typeface="Calibri" pitchFamily="34" charset="0"/>
+                <a:ea typeface="Calibri" pitchFamily="34" charset="-122"/>
+                <a:cs typeface="Calibri" pitchFamily="34" charset="-120"/>
+              </a:rPr>
+              <a:t>Jonas und Catharina: </a:t>
+            </a:r>
+            <a:r>
+              <a:rPr lang="en-US" sz="2200" dirty="0" err="1">
+                <a:solidFill>
+                  <a:srgbClr val="E6EDF3"/>
+                </a:solidFill>
+                <a:latin typeface="Calibri" pitchFamily="34" charset="0"/>
+                <a:ea typeface="Calibri" pitchFamily="34" charset="-122"/>
+                <a:cs typeface="Calibri" pitchFamily="34" charset="-120"/>
+              </a:rPr>
+              <a:t>Hilfe</a:t>
+            </a:r>
+            <a:r>
+              <a:rPr lang="en-US" sz="2200" dirty="0">
+                <a:solidFill>
+                  <a:srgbClr val="E6EDF3"/>
+                </a:solidFill>
+                <a:latin typeface="Calibri" pitchFamily="34" charset="0"/>
+                <a:ea typeface="Calibri" pitchFamily="34" charset="-122"/>
+                <a:cs typeface="Calibri" pitchFamily="34" charset="-120"/>
+              </a:rPr>
+              <a:t> und </a:t>
+            </a:r>
+            <a:r>
+              <a:rPr lang="en-US" sz="2200" dirty="0" err="1">
+                <a:solidFill>
+                  <a:srgbClr val="E6EDF3"/>
+                </a:solidFill>
+                <a:latin typeface="Calibri" pitchFamily="34" charset="0"/>
+                <a:ea typeface="Calibri" pitchFamily="34" charset="-122"/>
+                <a:cs typeface="Calibri" pitchFamily="34" charset="-120"/>
+              </a:rPr>
+              <a:t>Fehlerausgaben</a:t>
+            </a:r>
+            <a:endParaRPr lang="en-US" sz="2200" dirty="0"/>
+          </a:p>
+          <a:p>
+            <a:pPr marL="342900" indent="-342900">
+              <a:spcAft>
+                <a:spcPts val="800"/>
+              </a:spcAft>
+              <a:buSzPct val="100000"/>
+              <a:buChar char="•"/>
+            </a:pPr>
+            <a:r>
+              <a:rPr lang="en-US" sz="2200" dirty="0">
+                <a:solidFill>
+                  <a:srgbClr val="E6EDF3"/>
+                </a:solidFill>
+                <a:latin typeface="Calibri" pitchFamily="34" charset="0"/>
+                <a:ea typeface="Calibri" pitchFamily="34" charset="-122"/>
+                <a:cs typeface="Calibri" pitchFamily="34" charset="-120"/>
+              </a:rPr>
+              <a:t>Alle drei: Analyse, Recherche, Tests, Doku und Bugfixes</a:t>
+            </a:r>
+            <a:endParaRPr lang="en-US" sz="2200" dirty="0"/>
+          </a:p>
+        </p:txBody>
+      </p:sp>
+    </p:spTree>
+  </p:cSld>
+  <p:clrMapOvr>
+    <a:masterClrMapping/>
+  </p:clrMapOvr>
+</p:sld>
+</file>
+
+<file path=ppt/slides/slide8.xml><?xml version="1.0" encoding="utf-8"?>
 <p:sld xmlns:a="http://schemas.openxmlformats.org/drawingml/2006/main" xmlns:r="http://schemas.openxmlformats.org/officeDocument/2006/relationships" xmlns:p="http://schemas.openxmlformats.org/presentationml/2006/main">
   <p:cSld name="Slide 6">
     <p:bg>

</xml_diff>